<commit_message>
Site: lead with Zerion + add View deck button; deck: drop video placeholder
- Hero eyebrow leads with 'Built on Zerion CLI'
- New #zerion section showing what we forked vs. what we layered
- Nav: Zerion CLI link replaces Policies; Deck link added
- Hero + final CTA: View deck (PDF) button linking to /deck.pdf
- site/deck.pdf: current deck shipped alongside the site
- deck slide 9: third card is Website instead of placeholder video link
</commit_message>
<xml_diff>
--- a/deck/parasocial.pptx
+++ b/deck/parasocial.pptx
@@ -8180,7 +8180,7 @@
                 <a:ea typeface="Calibri" pitchFamily="34" charset="-122"/>
                 <a:cs typeface="Calibri" pitchFamily="34" charset="-120"/>
               </a:rPr>
-              <a:t>DEMO VIDEO</a:t>
+              <a:t>WEBSITE</a:t>
             </a:r>
             <a:endParaRPr lang="en-US" sz="1000" dirty="0"/>
           </a:p>
@@ -8219,7 +8219,7 @@
                 <a:ea typeface="Consolas" pitchFamily="34" charset="-122"/>
                 <a:cs typeface="Consolas" pitchFamily="34" charset="-120"/>
               </a:rPr>
-              <a:t>[ video link ]</a:t>
+              <a:t>frederik-maker.github.io/parasocial-bot</a:t>
             </a:r>
             <a:endParaRPr lang="en-US" sz="1500" dirty="0"/>
           </a:p>

</xml_diff>